<commit_message>
SCENIC workflow & archr.ppt
</commit_message>
<xml_diff>
--- a/SOFTWARE/ArchR/NOTEs/NOTE-archr/archr-atac.pptx
+++ b/SOFTWARE/ArchR/NOTEs/NOTE-archr/archr-atac.pptx
@@ -6,20 +6,21 @@
   </p:sldMasterIdLst>
   <p:sldIdLst>
     <p:sldId id="256" r:id="rId3"/>
-    <p:sldId id="258" r:id="rId4"/>
-    <p:sldId id="259" r:id="rId5"/>
-    <p:sldId id="260" r:id="rId6"/>
-    <p:sldId id="257" r:id="rId7"/>
-    <p:sldId id="261" r:id="rId8"/>
-    <p:sldId id="262" r:id="rId9"/>
-    <p:sldId id="263" r:id="rId10"/>
-    <p:sldId id="271" r:id="rId11"/>
-    <p:sldId id="264" r:id="rId12"/>
-    <p:sldId id="265" r:id="rId13"/>
-    <p:sldId id="266" r:id="rId14"/>
-    <p:sldId id="267" r:id="rId15"/>
-    <p:sldId id="268" r:id="rId16"/>
-    <p:sldId id="269" r:id="rId17"/>
+    <p:sldId id="279" r:id="rId4"/>
+    <p:sldId id="278" r:id="rId5"/>
+    <p:sldId id="258" r:id="rId6"/>
+    <p:sldId id="259" r:id="rId7"/>
+    <p:sldId id="260" r:id="rId8"/>
+    <p:sldId id="257" r:id="rId9"/>
+    <p:sldId id="261" r:id="rId10"/>
+    <p:sldId id="262" r:id="rId11"/>
+    <p:sldId id="263" r:id="rId12"/>
+    <p:sldId id="264" r:id="rId13"/>
+    <p:sldId id="265" r:id="rId14"/>
+    <p:sldId id="266" r:id="rId15"/>
+    <p:sldId id="267" r:id="rId16"/>
+    <p:sldId id="268" r:id="rId17"/>
+    <p:sldId id="269" r:id="rId18"/>
   </p:sldIdLst>
   <p:sldSz cx="12192000" cy="6858000"/>
   <p:notesSz cx="6858000" cy="9144000"/>
@@ -3073,7 +3074,7 @@
           <a:p>
             <a:r>
               <a:rPr lang="en-US" altLang="zh-CN"/>
-              <a:t>Per-cell Quality Control</a:t>
+              <a:t>Annotations of gene and genome</a:t>
             </a:r>
             <a:endParaRPr lang="en-US" altLang="zh-CN"/>
           </a:p>
@@ -3095,46 +3096,31 @@
           <a:p>
             <a:r>
               <a:rPr lang="en-US" altLang="zh-CN"/>
-              <a:t>The number of unique nuclear </a:t>
-            </a:r>
-            <a:r>
-              <a:rPr lang="en-US" altLang="zh-CN" b="1"/>
-              <a:t>fragments</a:t>
-            </a:r>
-            <a:r>
-              <a:rPr lang="en-US" altLang="zh-CN"/>
-              <a:t> (i.e. not mapping to mitochondrial DNA).</a:t>
-            </a:r>
-            <a:endParaRPr lang="en-US" altLang="zh-CN"/>
-          </a:p>
-          <a:p>
-            <a:r>
-              <a:rPr lang="en-US" altLang="zh-CN"/>
-              <a:t>The signal-to-background ratio (</a:t>
-            </a:r>
-            <a:r>
-              <a:rPr lang="en-US" altLang="zh-CN" b="1"/>
-              <a:t>TSS signal</a:t>
-            </a:r>
-            <a:r>
-              <a:rPr lang="en-US" altLang="zh-CN"/>
-              <a:t>). Low signal-to-background ratio is often attributed to dead or dying cells which have de-chromatinzed DNA which allows for random transposition genome-wide.</a:t>
-            </a:r>
-            <a:endParaRPr lang="en-US" altLang="zh-CN"/>
-          </a:p>
-          <a:p>
-            <a:r>
-              <a:rPr lang="en-US" altLang="zh-CN" b="1"/>
-              <a:t>The fragment size distribution</a:t>
-            </a:r>
-            <a:r>
-              <a:rPr lang="en-US" altLang="zh-CN"/>
-              <a:t>. Due to nucleosomal periodicity, we expect to see depletion of fragments that are the length of DNA wrapped around a nucleosome (approximately 147 bp).</a:t>
-            </a:r>
-            <a:endParaRPr lang="en-US" altLang="zh-CN"/>
-          </a:p>
-          <a:p>
-            <a:endParaRPr lang="en-US" altLang="zh-CN"/>
+              <a:t>ArchR requires gene and genome annotations to do things such as calculate TSS enrichment scores, nucleotide content, and gene activity scores.</a:t>
+            </a:r>
+            <a:endParaRPr lang="en-US" altLang="zh-CN"/>
+          </a:p>
+          <a:p>
+            <a:r>
+              <a:rPr lang="en-US" altLang="zh-CN"/>
+              <a:t>How to custom annotation? (1) from ArchR tutorial </a:t>
+            </a:r>
+            <a:r>
+              <a:rPr lang="en-US" altLang="zh-CN" i="1"/>
+              <a:t>https://www.archrproject.com/bookdown/getting-set-up.html#creating-a-custom-archrgenome</a:t>
+            </a:r>
+            <a:r>
+              <a:rPr lang="en-US" altLang="zh-CN"/>
+              <a:t> (2) from omics4plant </a:t>
+            </a:r>
+            <a:r>
+              <a:rPr lang="en-US" altLang="zh-CN" i="1"/>
+              <a:t>https://github.com/ydgenomics/omics4plant/tree/main/SOFTWARE/ArchR/NOTEs/NOTE-region_annotation</a:t>
+            </a:r>
+            <a:endParaRPr lang="en-US" altLang="zh-CN" i="1"/>
+          </a:p>
+          <a:p>
+            <a:endParaRPr lang="en-US" altLang="zh-CN" i="1"/>
           </a:p>
         </p:txBody>
       </p:sp>
@@ -3172,7 +3158,7 @@
           <a:p>
             <a:r>
               <a:rPr lang="en-US" altLang="zh-CN"/>
-              <a:t>Remove doublet</a:t>
+              <a:t>Per-cell Quality Control</a:t>
             </a:r>
             <a:endParaRPr lang="en-US" altLang="zh-CN"/>
           </a:p>
@@ -3188,63 +3174,55 @@
             <p:ph idx="1"/>
           </p:nvPr>
         </p:nvSpPr>
-        <p:spPr>
-          <a:xfrm>
-            <a:off x="300355" y="1385570"/>
-            <a:ext cx="11639550" cy="2941320"/>
-          </a:xfrm>
-        </p:spPr>
-        <p:txBody>
-          <a:bodyPr>
-            <a:normAutofit fontScale="70000"/>
-          </a:bodyPr>
-          <a:p>
-            <a:r>
-              <a:rPr lang="en-US" altLang="zh-CN"/>
-              <a:t>Doublet Enrichments - These represent the enrichment of simulated doublets nearby each single cell compared to the expected if we assume a uniform distribution.</a:t>
-            </a:r>
-            <a:endParaRPr lang="en-US" altLang="zh-CN"/>
-          </a:p>
-          <a:p>
-            <a:r>
-              <a:rPr lang="en-US" altLang="zh-CN"/>
-              <a:t>Doublet Scores - These represent the significance (-log10(binomial adjusted p-value)) of simulated doublets nearby each single cell compared to the expected if we assume a uniform distribution. We have found this value to be less consistent than the doublet enrichments and therefore use doublet enrichments for doublet identification.</a:t>
-            </a:r>
-            <a:endParaRPr lang="en-US" altLang="zh-CN"/>
-          </a:p>
-          <a:p>
-            <a:r>
-              <a:rPr lang="en-US" altLang="zh-CN"/>
-              <a:t>Doublet Density - This represents the density of the simulated doublet projections. This allows you to visualize where the synthetic doublets were located after projection into your 2-dimensional embedding.</a:t>
-            </a:r>
-            <a:endParaRPr lang="en-US" altLang="zh-CN"/>
-          </a:p>
-        </p:txBody>
-      </p:sp>
-      <p:pic>
-        <p:nvPicPr>
-          <p:cNvPr id="4" name="图片 3"/>
-          <p:cNvPicPr>
-            <a:picLocks noChangeAspect="1"/>
-          </p:cNvPicPr>
-          <p:nvPr/>
-        </p:nvPicPr>
-        <p:blipFill>
-          <a:blip r:embed="rId1"/>
-          <a:stretch>
-            <a:fillRect/>
-          </a:stretch>
-        </p:blipFill>
-        <p:spPr>
-          <a:xfrm>
-            <a:off x="1078230" y="3930650"/>
-            <a:ext cx="9398635" cy="2860675"/>
-          </a:xfrm>
-          <a:prstGeom prst="rect">
-            <a:avLst/>
-          </a:prstGeom>
-        </p:spPr>
-      </p:pic>
+        <p:spPr/>
+        <p:txBody>
+          <a:bodyPr/>
+          <a:p>
+            <a:r>
+              <a:rPr lang="en-US" altLang="zh-CN"/>
+              <a:t>The number of unique nuclear </a:t>
+            </a:r>
+            <a:r>
+              <a:rPr lang="en-US" altLang="zh-CN" b="1"/>
+              <a:t>fragments</a:t>
+            </a:r>
+            <a:r>
+              <a:rPr lang="en-US" altLang="zh-CN"/>
+              <a:t> (i.e. not mapping to mitochondrial DNA).</a:t>
+            </a:r>
+            <a:endParaRPr lang="en-US" altLang="zh-CN"/>
+          </a:p>
+          <a:p>
+            <a:r>
+              <a:rPr lang="en-US" altLang="zh-CN"/>
+              <a:t>The signal-to-background ratio (</a:t>
+            </a:r>
+            <a:r>
+              <a:rPr lang="en-US" altLang="zh-CN" b="1"/>
+              <a:t>TSS signal</a:t>
+            </a:r>
+            <a:r>
+              <a:rPr lang="en-US" altLang="zh-CN"/>
+              <a:t>). Low signal-to-background ratio is often attributed to dead or dying cells which have de-chromatinzed DNA which allows for random transposition genome-wide.</a:t>
+            </a:r>
+            <a:endParaRPr lang="en-US" altLang="zh-CN"/>
+          </a:p>
+          <a:p>
+            <a:r>
+              <a:rPr lang="en-US" altLang="zh-CN" b="1"/>
+              <a:t>The fragment size distribution</a:t>
+            </a:r>
+            <a:r>
+              <a:rPr lang="en-US" altLang="zh-CN"/>
+              <a:t>. Due to nucleosomal periodicity, we expect to see depletion of fragments that are the length of DNA wrapped around a nucleosome (approximately 147 bp).</a:t>
+            </a:r>
+            <a:endParaRPr lang="en-US" altLang="zh-CN"/>
+          </a:p>
+          <a:p>
+            <a:endParaRPr lang="en-US" altLang="zh-CN"/>
+          </a:p>
+        </p:txBody>
+      </p:sp>
     </p:spTree>
   </p:cSld>
   <p:clrMapOvr>
@@ -3279,7 +3257,7 @@
           <a:p>
             <a:r>
               <a:rPr lang="en-US" altLang="zh-CN"/>
-              <a:t>ArchRProject@cellColData</a:t>
+              <a:t>Remove doublet</a:t>
             </a:r>
             <a:endParaRPr lang="en-US" altLang="zh-CN"/>
           </a:p>
@@ -3297,100 +3275,61 @@
         </p:nvSpPr>
         <p:spPr>
           <a:xfrm>
-            <a:off x="215265" y="1217930"/>
-            <a:ext cx="11138535" cy="5536565"/>
+            <a:off x="300355" y="1385570"/>
+            <a:ext cx="11639550" cy="2941320"/>
           </a:xfrm>
         </p:spPr>
         <p:txBody>
           <a:bodyPr>
-            <a:normAutofit fontScale="80000"/>
+            <a:normAutofit fontScale="70000"/>
           </a:bodyPr>
           <a:p>
             <a:r>
               <a:rPr lang="en-US" altLang="zh-CN"/>
-              <a:t>proj$TSSEnrichment (float)</a:t>
-            </a:r>
-            <a:endParaRPr lang="en-US" altLang="zh-CN"/>
-          </a:p>
-          <a:p>
-            <a:r>
-              <a:rPr lang="en-US" altLang="zh-CN"/>
-              <a:t>proj$ReadsInTSS (integer)</a:t>
-            </a:r>
-            <a:endParaRPr lang="en-US" altLang="zh-CN"/>
-          </a:p>
-          <a:p>
-            <a:r>
-              <a:rPr lang="en-US" altLang="zh-CN"/>
-              <a:t>proj$ReadsInPromotor (integer) NOTE: promoter regions is -2000 to + 100 from the TSS</a:t>
-            </a:r>
-            <a:endParaRPr lang="en-US" altLang="zh-CN"/>
-          </a:p>
-          <a:p>
-            <a:r>
-              <a:rPr lang="en-US" altLang="zh-CN"/>
-              <a:t>proj$PromoterRatio (float)</a:t>
-            </a:r>
-            <a:endParaRPr lang="en-US" altLang="zh-CN"/>
-          </a:p>
-          <a:p>
-            <a:r>
-              <a:rPr lang="en-US" altLang="zh-CN"/>
-              <a:t>proj$ReadsInBlacklist (integer) NOTE: blacklist include some unwanted mapped regions such as mito and chloroplast.</a:t>
-            </a:r>
-            <a:endParaRPr lang="en-US" altLang="zh-CN"/>
-          </a:p>
-          <a:p>
-            <a:r>
-              <a:rPr lang="en-US" altLang="zh-CN"/>
-              <a:t>proj$BlacklistRatio (float)</a:t>
-            </a:r>
-            <a:endParaRPr lang="en-US" altLang="zh-CN"/>
-          </a:p>
-          <a:p>
-            <a:r>
-              <a:rPr lang="en-US" altLang="zh-CN"/>
-              <a:t>proj$NucleosomeRatio (float)</a:t>
-            </a:r>
-            <a:endParaRPr lang="en-US" altLang="zh-CN"/>
-          </a:p>
-          <a:p>
-            <a:r>
-              <a:rPr lang="en-US" altLang="zh-CN"/>
-              <a:t>proj$nFrags (integer)</a:t>
-            </a:r>
-            <a:endParaRPr lang="en-US" altLang="zh-CN"/>
-          </a:p>
-          <a:p>
-            <a:r>
-              <a:rPr lang="en-US" altLang="zh-CN"/>
-              <a:t>proj$nMonoFrags (integer) &gt; 147bp but &lt;  2*147bp</a:t>
-            </a:r>
-            <a:endParaRPr lang="en-US" altLang="zh-CN"/>
-          </a:p>
-          <a:p>
-            <a:r>
-              <a:rPr lang="en-US" altLang="zh-CN"/>
-              <a:t>proj$nDiFrags (integer) &gt; 2*147bp but &lt; 3*147bp</a:t>
-            </a:r>
-            <a:endParaRPr lang="en-US" altLang="zh-CN"/>
-          </a:p>
-          <a:p>
-            <a:r>
-              <a:rPr lang="en-US" altLang="zh-CN"/>
-              <a:t>proj#nMultiFrags (integer) &gt; 3*147bp</a:t>
-            </a:r>
-            <a:endParaRPr lang="en-US" altLang="zh-CN"/>
-          </a:p>
-          <a:p>
-            <a:r>
-              <a:rPr lang="en-US" altLang="zh-CN"/>
-              <a:t>proj$PassQC (integer, 1 mean passed; 0 mean not)</a:t>
-            </a:r>
-            <a:endParaRPr lang="en-US" altLang="zh-CN"/>
-          </a:p>
-        </p:txBody>
-      </p:sp>
+              <a:t>Doublet Enrichments - These represent the enrichment of simulated doublets nearby each single cell compared to the expected if we assume a uniform distribution.</a:t>
+            </a:r>
+            <a:endParaRPr lang="en-US" altLang="zh-CN"/>
+          </a:p>
+          <a:p>
+            <a:r>
+              <a:rPr lang="en-US" altLang="zh-CN"/>
+              <a:t>Doublet Scores - These represent the significance (-log10(binomial adjusted p-value)) of simulated doublets nearby each single cell compared to the expected if we assume a uniform distribution. We have found this value to be less consistent than the doublet enrichments and therefore use doublet enrichments for doublet identification.</a:t>
+            </a:r>
+            <a:endParaRPr lang="en-US" altLang="zh-CN"/>
+          </a:p>
+          <a:p>
+            <a:r>
+              <a:rPr lang="en-US" altLang="zh-CN"/>
+              <a:t>Doublet Density - This represents the density of the simulated doublet projections. This allows you to visualize where the synthetic doublets were located after projection into your 2-dimensional embedding.</a:t>
+            </a:r>
+            <a:endParaRPr lang="en-US" altLang="zh-CN"/>
+          </a:p>
+        </p:txBody>
+      </p:sp>
+      <p:pic>
+        <p:nvPicPr>
+          <p:cNvPr id="4" name="图片 3"/>
+          <p:cNvPicPr>
+            <a:picLocks noChangeAspect="1"/>
+          </p:cNvPicPr>
+          <p:nvPr/>
+        </p:nvPicPr>
+        <p:blipFill>
+          <a:blip r:embed="rId1"/>
+          <a:stretch>
+            <a:fillRect/>
+          </a:stretch>
+        </p:blipFill>
+        <p:spPr>
+          <a:xfrm>
+            <a:off x="1078230" y="3930650"/>
+            <a:ext cx="9398635" cy="2860675"/>
+          </a:xfrm>
+          <a:prstGeom prst="rect">
+            <a:avLst/>
+          </a:prstGeom>
+        </p:spPr>
+      </p:pic>
     </p:spTree>
   </p:cSld>
   <p:clrMapOvr>
@@ -3425,7 +3364,7 @@
           <a:p>
             <a:r>
               <a:rPr lang="en-US" altLang="zh-CN"/>
-              <a:t>Cluster </a:t>
+              <a:t>ArchRProject@cellColData</a:t>
             </a:r>
             <a:endParaRPr lang="en-US" altLang="zh-CN"/>
           </a:p>
@@ -3441,24 +3380,97 @@
             <p:ph idx="1"/>
           </p:nvPr>
         </p:nvSpPr>
-        <p:spPr/>
-        <p:txBody>
-          <a:bodyPr/>
-          <a:p>
-            <a:r>
-              <a:rPr lang="en-US" altLang="zh-CN"/>
-              <a:t>Seurat’s method F</a:t>
-            </a:r>
-            <a:r>
-              <a:rPr lang="en-US" altLang="zh-CN"/>
-              <a:t>indClusters()</a:t>
-            </a:r>
-            <a:endParaRPr lang="en-US" altLang="zh-CN"/>
-          </a:p>
-          <a:p>
-            <a:r>
-              <a:rPr lang="en-US" altLang="zh-CN"/>
-              <a:t>scran</a:t>
+        <p:spPr>
+          <a:xfrm>
+            <a:off x="215265" y="1217930"/>
+            <a:ext cx="11138535" cy="5536565"/>
+          </a:xfrm>
+        </p:spPr>
+        <p:txBody>
+          <a:bodyPr>
+            <a:normAutofit fontScale="80000"/>
+          </a:bodyPr>
+          <a:p>
+            <a:r>
+              <a:rPr lang="en-US" altLang="zh-CN"/>
+              <a:t>proj$TSSEnrichment (float)</a:t>
+            </a:r>
+            <a:endParaRPr lang="en-US" altLang="zh-CN"/>
+          </a:p>
+          <a:p>
+            <a:r>
+              <a:rPr lang="en-US" altLang="zh-CN"/>
+              <a:t>proj$ReadsInTSS (integer)</a:t>
+            </a:r>
+            <a:endParaRPr lang="en-US" altLang="zh-CN"/>
+          </a:p>
+          <a:p>
+            <a:r>
+              <a:rPr lang="en-US" altLang="zh-CN"/>
+              <a:t>proj$ReadsInPromotor (integer) NOTE: promoter regions is -2000 to + 100 from the TSS</a:t>
+            </a:r>
+            <a:endParaRPr lang="en-US" altLang="zh-CN"/>
+          </a:p>
+          <a:p>
+            <a:r>
+              <a:rPr lang="en-US" altLang="zh-CN"/>
+              <a:t>proj$PromoterRatio (float)</a:t>
+            </a:r>
+            <a:endParaRPr lang="en-US" altLang="zh-CN"/>
+          </a:p>
+          <a:p>
+            <a:r>
+              <a:rPr lang="en-US" altLang="zh-CN"/>
+              <a:t>proj$ReadsInBlacklist (integer) NOTE: blacklist include some unwanted mapped regions such as mito and chloroplast.</a:t>
+            </a:r>
+            <a:endParaRPr lang="en-US" altLang="zh-CN"/>
+          </a:p>
+          <a:p>
+            <a:r>
+              <a:rPr lang="en-US" altLang="zh-CN"/>
+              <a:t>proj$BlacklistRatio (float)</a:t>
+            </a:r>
+            <a:endParaRPr lang="en-US" altLang="zh-CN"/>
+          </a:p>
+          <a:p>
+            <a:r>
+              <a:rPr lang="en-US" altLang="zh-CN"/>
+              <a:t>proj$NucleosomeRatio (float)</a:t>
+            </a:r>
+            <a:endParaRPr lang="en-US" altLang="zh-CN"/>
+          </a:p>
+          <a:p>
+            <a:r>
+              <a:rPr lang="en-US" altLang="zh-CN"/>
+              <a:t>proj$nFrags (integer)</a:t>
+            </a:r>
+            <a:endParaRPr lang="en-US" altLang="zh-CN"/>
+          </a:p>
+          <a:p>
+            <a:r>
+              <a:rPr lang="en-US" altLang="zh-CN"/>
+              <a:t>proj$nMonoFrags (integer) &gt; 147bp but &lt;  2*147bp</a:t>
+            </a:r>
+            <a:endParaRPr lang="en-US" altLang="zh-CN"/>
+          </a:p>
+          <a:p>
+            <a:r>
+              <a:rPr lang="en-US" altLang="zh-CN"/>
+              <a:t>proj$nDiFrags (integer) &gt; 2*147bp but &lt; 3*147bp</a:t>
+            </a:r>
+            <a:endParaRPr lang="en-US" altLang="zh-CN"/>
+          </a:p>
+          <a:p>
+            <a:r>
+              <a:rPr lang="en-US" altLang="zh-CN"/>
+              <a:t>proj#nMultiFrags (integer) &gt; 3*147bp</a:t>
+            </a:r>
+            <a:endParaRPr lang="en-US" altLang="zh-CN"/>
+          </a:p>
+          <a:p>
+            <a:r>
+              <a:rPr lang="en-US" altLang="zh-CN"/>
+              <a:t>proj$PassQC (integer, 1 mean passed; 0 mean not)</a:t>
             </a:r>
             <a:endParaRPr lang="en-US" altLang="zh-CN"/>
           </a:p>
@@ -3498,7 +3510,7 @@
           <a:p>
             <a:r>
               <a:rPr lang="en-US" altLang="zh-CN"/>
-              <a:t>Reduction &amp; embedding</a:t>
+              <a:t>Cluster </a:t>
             </a:r>
             <a:endParaRPr lang="en-US" altLang="zh-CN"/>
           </a:p>
@@ -3520,21 +3532,18 @@
           <a:p>
             <a:r>
               <a:rPr lang="en-US" altLang="zh-CN"/>
-              <a:t>umap </a:t>
-            </a:r>
-            <a:endParaRPr lang="en-US" altLang="zh-CN"/>
-          </a:p>
-          <a:p>
-            <a:r>
-              <a:rPr lang="en-US" altLang="zh-CN"/>
-              <a:t>LSI</a:t>
-            </a:r>
-            <a:endParaRPr lang="en-US" altLang="zh-CN"/>
-          </a:p>
-          <a:p>
-            <a:r>
-              <a:rPr lang="en-US" altLang="zh-CN"/>
-              <a:t>tSNE</a:t>
+              <a:t>Seurat’s method F</a:t>
+            </a:r>
+            <a:r>
+              <a:rPr lang="en-US" altLang="zh-CN"/>
+              <a:t>indClusters()</a:t>
+            </a:r>
+            <a:endParaRPr lang="en-US" altLang="zh-CN"/>
+          </a:p>
+          <a:p>
+            <a:r>
+              <a:rPr lang="en-US" altLang="zh-CN"/>
+              <a:t>scran</a:t>
             </a:r>
             <a:endParaRPr lang="en-US" altLang="zh-CN"/>
           </a:p>
@@ -3574,6 +3583,82 @@
           <a:p>
             <a:r>
               <a:rPr lang="en-US" altLang="zh-CN"/>
+              <a:t>Reduction &amp; embedding</a:t>
+            </a:r>
+            <a:endParaRPr lang="en-US" altLang="zh-CN"/>
+          </a:p>
+        </p:txBody>
+      </p:sp>
+      <p:sp>
+        <p:nvSpPr>
+          <p:cNvPr id="3" name="内容占位符 2"/>
+          <p:cNvSpPr>
+            <a:spLocks noGrp="1"/>
+          </p:cNvSpPr>
+          <p:nvPr>
+            <p:ph idx="1"/>
+          </p:nvPr>
+        </p:nvSpPr>
+        <p:spPr/>
+        <p:txBody>
+          <a:bodyPr/>
+          <a:p>
+            <a:r>
+              <a:rPr lang="en-US" altLang="zh-CN"/>
+              <a:t>umap </a:t>
+            </a:r>
+            <a:endParaRPr lang="en-US" altLang="zh-CN"/>
+          </a:p>
+          <a:p>
+            <a:r>
+              <a:rPr lang="en-US" altLang="zh-CN"/>
+              <a:t>LSI</a:t>
+            </a:r>
+            <a:endParaRPr lang="en-US" altLang="zh-CN"/>
+          </a:p>
+          <a:p>
+            <a:r>
+              <a:rPr lang="en-US" altLang="zh-CN"/>
+              <a:t>tSNE</a:t>
+            </a:r>
+            <a:endParaRPr lang="en-US" altLang="zh-CN"/>
+          </a:p>
+        </p:txBody>
+      </p:sp>
+    </p:spTree>
+  </p:cSld>
+  <p:clrMapOvr>
+    <a:masterClrMapping/>
+  </p:clrMapOvr>
+</p:sld>
+</file>
+
+<file path=ppt/slides/slide16.xml><?xml version="1.0" encoding="utf-8"?>
+<p:sld xmlns:a="http://schemas.openxmlformats.org/drawingml/2006/main" xmlns:r="http://schemas.openxmlformats.org/officeDocument/2006/relationships" xmlns:p="http://schemas.openxmlformats.org/presentationml/2006/main">
+  <p:cSld>
+    <p:spTree>
+      <p:nvGrpSpPr>
+        <p:cNvPr id="1" name=""/>
+        <p:cNvGrpSpPr/>
+        <p:nvPr/>
+      </p:nvGrpSpPr>
+      <p:grpSpPr/>
+      <p:sp>
+        <p:nvSpPr>
+          <p:cNvPr id="2" name="标题 1"/>
+          <p:cNvSpPr>
+            <a:spLocks noGrp="1"/>
+          </p:cNvSpPr>
+          <p:nvPr>
+            <p:ph type="title"/>
+          </p:nvPr>
+        </p:nvSpPr>
+        <p:spPr/>
+        <p:txBody>
+          <a:bodyPr/>
+          <a:p>
+            <a:r>
+              <a:rPr lang="en-US" altLang="zh-CN"/>
               <a:t>Footprint</a:t>
             </a:r>
             <a:endParaRPr lang="en-US" altLang="zh-CN"/>
@@ -3700,38 +3785,57 @@
             <a:spLocks noGrp="1"/>
           </p:cNvSpPr>
           <p:nvPr>
-            <p:ph type="ctrTitle"/>
-          </p:nvPr>
-        </p:nvSpPr>
-        <p:spPr>
-          <a:xfrm>
-            <a:off x="527050" y="2284095"/>
-            <a:ext cx="11305540" cy="1144905"/>
-          </a:xfrm>
-        </p:spPr>
-        <p:txBody>
-          <a:bodyPr>
-            <a:normAutofit/>
-          </a:bodyPr>
-          <a:p>
-            <a:r>
-              <a:rPr lang="en-US" altLang="zh-CN"/>
-              <a:t>How to interpret scATAC-seq data?</a:t>
-            </a:r>
-            <a:endParaRPr lang="en-US" altLang="zh-CN"/>
-          </a:p>
-        </p:txBody>
-      </p:sp>
-      <p:sp>
-        <p:nvSpPr>
-          <p:cNvPr id="4" name="文本框 3"/>
+            <p:ph type="title"/>
+          </p:nvPr>
+        </p:nvSpPr>
+        <p:spPr/>
+        <p:txBody>
+          <a:bodyPr/>
+          <a:p>
+            <a:r>
+              <a:rPr lang="en-US" altLang="zh-CN"/>
+              <a:t>before run ArchR</a:t>
+            </a:r>
+            <a:endParaRPr lang="en-US" altLang="zh-CN"/>
+          </a:p>
+        </p:txBody>
+      </p:sp>
+      <p:pic>
+        <p:nvPicPr>
+          <p:cNvPr id="4" name="内容占位符 3"/>
+          <p:cNvPicPr>
+            <a:picLocks noChangeAspect="1"/>
+          </p:cNvPicPr>
+          <p:nvPr>
+            <p:ph idx="1"/>
+          </p:nvPr>
+        </p:nvPicPr>
+        <p:blipFill>
+          <a:blip r:embed="rId1"/>
+          <a:stretch>
+            <a:fillRect/>
+          </a:stretch>
+        </p:blipFill>
+        <p:spPr>
+          <a:xfrm>
+            <a:off x="740410" y="2008505"/>
+            <a:ext cx="10515600" cy="2840990"/>
+          </a:xfrm>
+          <a:prstGeom prst="rect">
+            <a:avLst/>
+          </a:prstGeom>
+        </p:spPr>
+      </p:pic>
+      <p:sp>
+        <p:nvSpPr>
+          <p:cNvPr id="5" name="文本框 4"/>
           <p:cNvSpPr txBox="1"/>
           <p:nvPr/>
         </p:nvSpPr>
         <p:spPr>
           <a:xfrm>
-            <a:off x="2700020" y="6280150"/>
-            <a:ext cx="8583930" cy="368300"/>
+            <a:off x="3458845" y="5166995"/>
+            <a:ext cx="4064000" cy="368300"/>
           </a:xfrm>
           <a:prstGeom prst="rect">
             <a:avLst/>
@@ -3744,8 +3848,20 @@
           </a:bodyPr>
           <a:p>
             <a:r>
-              <a:rPr lang="en-US" altLang="zh-CN"/>
-              <a:t>https://www.scdiscoveries.com/blog/knowledge/how-scatac-seq-works/</a:t>
+              <a:rPr lang="zh-CN" altLang="en-US"/>
+              <a:t>输入参考基因组的</a:t>
+            </a:r>
+            <a:r>
+              <a:rPr lang="en-US" altLang="zh-CN"/>
+              <a:t>fa</a:t>
+            </a:r>
+            <a:r>
+              <a:rPr lang="zh-CN" altLang="en-US"/>
+              <a:t>和</a:t>
+            </a:r>
+            <a:r>
+              <a:rPr lang="en-US" altLang="zh-CN"/>
+              <a:t>gtf</a:t>
             </a:r>
             <a:endParaRPr lang="en-US" altLang="zh-CN"/>
           </a:p>
@@ -3785,7 +3901,174 @@
           <a:p>
             <a:r>
               <a:rPr lang="en-US" altLang="zh-CN"/>
-              <a:t>What are ACRs and peaks?</a:t>
+              <a:t>demo and script of A</a:t>
+            </a:r>
+            <a:r>
+              <a:rPr lang="en-US" altLang="zh-CN"/>
+              <a:t>rchR</a:t>
+            </a:r>
+            <a:endParaRPr lang="en-US" altLang="zh-CN"/>
+          </a:p>
+        </p:txBody>
+      </p:sp>
+      <p:sp>
+        <p:nvSpPr>
+          <p:cNvPr id="3" name="内容占位符 2"/>
+          <p:cNvSpPr>
+            <a:spLocks noGrp="1"/>
+          </p:cNvSpPr>
+          <p:nvPr>
+            <p:ph idx="1"/>
+          </p:nvPr>
+        </p:nvSpPr>
+        <p:spPr/>
+        <p:txBody>
+          <a:bodyPr/>
+          <a:p>
+            <a:r>
+              <a:rPr lang="en-US" altLang="zh-CN"/>
+              <a:t>/Files/User/yangdong/SOFTWARE/archr/  (</a:t>
+            </a:r>
+            <a:r>
+              <a:rPr lang="zh-CN" altLang="en-US"/>
+              <a:t>武汉</a:t>
+            </a:r>
+            <a:r>
+              <a:rPr lang="en-US" altLang="zh-CN"/>
+              <a:t>148)</a:t>
+            </a:r>
+            <a:endParaRPr lang="en-US" altLang="zh-CN"/>
+          </a:p>
+          <a:p>
+            <a:r>
+              <a:rPr lang="en-US" altLang="zh-CN"/>
+              <a:t>https://github.com/ydgenomics/omics4plant/tree/main/SOFTWARE/ArchR/WORKFLOW/SCRIPTs (github)</a:t>
+            </a:r>
+            <a:endParaRPr lang="en-US" altLang="zh-CN"/>
+          </a:p>
+        </p:txBody>
+      </p:sp>
+      <p:pic>
+        <p:nvPicPr>
+          <p:cNvPr id="4" name="图片 3"/>
+          <p:cNvPicPr>
+            <a:picLocks noChangeAspect="1"/>
+          </p:cNvPicPr>
+          <p:nvPr/>
+        </p:nvPicPr>
+        <p:blipFill>
+          <a:blip r:embed="rId1"/>
+          <a:stretch>
+            <a:fillRect/>
+          </a:stretch>
+        </p:blipFill>
+        <p:spPr>
+          <a:xfrm>
+            <a:off x="392430" y="3425825"/>
+            <a:ext cx="7317105" cy="2781300"/>
+          </a:xfrm>
+          <a:prstGeom prst="rect">
+            <a:avLst/>
+          </a:prstGeom>
+        </p:spPr>
+      </p:pic>
+      <p:sp>
+        <p:nvSpPr>
+          <p:cNvPr id="6" name="文本框 5"/>
+          <p:cNvSpPr txBox="1"/>
+          <p:nvPr/>
+        </p:nvSpPr>
+        <p:spPr>
+          <a:xfrm>
+            <a:off x="8128000" y="6085205"/>
+            <a:ext cx="4064000" cy="368300"/>
+          </a:xfrm>
+          <a:prstGeom prst="rect">
+            <a:avLst/>
+          </a:prstGeom>
+          <a:noFill/>
+        </p:spPr>
+        <p:txBody>
+          <a:bodyPr wrap="square" rtlCol="0">
+            <a:spAutoFit/>
+          </a:bodyPr>
+          <a:p>
+            <a:r>
+              <a:rPr lang="zh-CN" altLang="en-US"/>
+              <a:t>使用</a:t>
+            </a:r>
+            <a:r>
+              <a:rPr lang="en-US" altLang="zh-CN"/>
+              <a:t>shell</a:t>
+            </a:r>
+            <a:r>
+              <a:rPr lang="zh-CN" altLang="en-US"/>
+              <a:t>代码整体</a:t>
+            </a:r>
+            <a:r>
+              <a:rPr lang="en-US" altLang="zh-CN"/>
+              <a:t>R</a:t>
+            </a:r>
+            <a:r>
+              <a:rPr lang="zh-CN" altLang="en-US"/>
+              <a:t>脚本</a:t>
+            </a:r>
+            <a:endParaRPr lang="zh-CN" altLang="en-US"/>
+          </a:p>
+        </p:txBody>
+      </p:sp>
+      <p:pic>
+        <p:nvPicPr>
+          <p:cNvPr id="7" name="图片 6"/>
+          <p:cNvPicPr>
+            <a:picLocks noChangeAspect="1"/>
+          </p:cNvPicPr>
+          <p:nvPr/>
+        </p:nvPicPr>
+        <p:blipFill>
+          <a:blip r:embed="rId2"/>
+          <a:stretch>
+            <a:fillRect/>
+          </a:stretch>
+        </p:blipFill>
+        <p:spPr>
+          <a:xfrm>
+            <a:off x="8251190" y="3288030"/>
+            <a:ext cx="2860040" cy="2797175"/>
+          </a:xfrm>
+          <a:prstGeom prst="rect">
+            <a:avLst/>
+          </a:prstGeom>
+        </p:spPr>
+      </p:pic>
+      <p:sp>
+        <p:nvSpPr>
+          <p:cNvPr id="8" name="文本框 7"/>
+          <p:cNvSpPr txBox="1"/>
+          <p:nvPr/>
+        </p:nvSpPr>
+        <p:spPr>
+          <a:xfrm>
+            <a:off x="567690" y="6377940"/>
+            <a:ext cx="6118860" cy="368300"/>
+          </a:xfrm>
+          <a:prstGeom prst="rect">
+            <a:avLst/>
+          </a:prstGeom>
+          <a:noFill/>
+        </p:spPr>
+        <p:txBody>
+          <a:bodyPr wrap="square" rtlCol="0">
+            <a:spAutoFit/>
+          </a:bodyPr>
+          <a:p>
+            <a:r>
+              <a:rPr lang="zh-CN" altLang="en-US"/>
+              <a:t>公共库镜像：</a:t>
+            </a:r>
+            <a:r>
+              <a:rPr lang="en-US" altLang="zh-CN"/>
+              <a:t>ArchR_Macs2_ChromVARmotifs</a:t>
             </a:r>
             <a:endParaRPr lang="en-US" altLang="zh-CN"/>
           </a:p>
@@ -3816,47 +4099,57 @@
             <a:spLocks noGrp="1"/>
           </p:cNvSpPr>
           <p:nvPr>
-            <p:ph type="title"/>
-          </p:nvPr>
-        </p:nvSpPr>
-        <p:spPr/>
-        <p:txBody>
-          <a:bodyPr/>
-          <a:p>
-            <a:r>
-              <a:rPr lang="en-US" altLang="zh-CN"/>
-              <a:t>The distribution of ACRs.</a:t>
-            </a:r>
-            <a:endParaRPr lang="en-US" altLang="zh-CN"/>
-          </a:p>
-        </p:txBody>
-      </p:sp>
-      <p:pic>
-        <p:nvPicPr>
-          <p:cNvPr id="4" name="内容占位符 3"/>
-          <p:cNvPicPr>
-            <a:picLocks noChangeAspect="1"/>
-          </p:cNvPicPr>
-          <p:nvPr>
-            <p:ph idx="1"/>
-          </p:nvPr>
-        </p:nvPicPr>
-        <p:blipFill>
-          <a:blip r:embed="rId1"/>
-          <a:stretch>
-            <a:fillRect/>
-          </a:stretch>
-        </p:blipFill>
-        <p:spPr>
-          <a:xfrm>
-            <a:off x="606425" y="1691005"/>
-            <a:ext cx="3543300" cy="3543300"/>
+            <p:ph type="ctrTitle"/>
+          </p:nvPr>
+        </p:nvSpPr>
+        <p:spPr>
+          <a:xfrm>
+            <a:off x="527050" y="2284095"/>
+            <a:ext cx="11305540" cy="1144905"/>
+          </a:xfrm>
+        </p:spPr>
+        <p:txBody>
+          <a:bodyPr>
+            <a:normAutofit/>
+          </a:bodyPr>
+          <a:p>
+            <a:r>
+              <a:rPr lang="en-US" altLang="zh-CN"/>
+              <a:t>How to interpret scATAC-seq data?</a:t>
+            </a:r>
+            <a:endParaRPr lang="en-US" altLang="zh-CN"/>
+          </a:p>
+        </p:txBody>
+      </p:sp>
+      <p:sp>
+        <p:nvSpPr>
+          <p:cNvPr id="4" name="文本框 3"/>
+          <p:cNvSpPr txBox="1"/>
+          <p:nvPr/>
+        </p:nvSpPr>
+        <p:spPr>
+          <a:xfrm>
+            <a:off x="2700020" y="6280150"/>
+            <a:ext cx="8583930" cy="368300"/>
           </a:xfrm>
           <a:prstGeom prst="rect">
             <a:avLst/>
           </a:prstGeom>
-        </p:spPr>
-      </p:pic>
+          <a:noFill/>
+        </p:spPr>
+        <p:txBody>
+          <a:bodyPr wrap="square" rtlCol="0">
+            <a:spAutoFit/>
+          </a:bodyPr>
+          <a:p>
+            <a:r>
+              <a:rPr lang="en-US" altLang="zh-CN"/>
+              <a:t>https://www.scdiscoveries.com/blog/knowledge/how-scatac-seq-works/</a:t>
+            </a:r>
+            <a:endParaRPr lang="en-US" altLang="zh-CN"/>
+          </a:p>
+        </p:txBody>
+      </p:sp>
     </p:spTree>
   </p:cSld>
   <p:clrMapOvr>
@@ -3891,152 +4184,12 @@
           <a:p>
             <a:r>
               <a:rPr lang="en-US" altLang="zh-CN"/>
-              <a:t>ACRs means trascription?</a:t>
-            </a:r>
-            <a:endParaRPr lang="en-US" altLang="zh-CN"/>
-          </a:p>
-        </p:txBody>
-      </p:sp>
-      <p:pic>
-        <p:nvPicPr>
-          <p:cNvPr id="4" name="内容占位符 3"/>
-          <p:cNvPicPr>
-            <a:picLocks noChangeAspect="1"/>
-          </p:cNvPicPr>
-          <p:nvPr>
-            <p:ph idx="1"/>
-          </p:nvPr>
-        </p:nvPicPr>
-        <p:blipFill>
-          <a:blip r:embed="rId1"/>
-          <a:stretch>
-            <a:fillRect/>
-          </a:stretch>
-        </p:blipFill>
-        <p:spPr>
-          <a:xfrm>
-            <a:off x="926465" y="1358265"/>
-            <a:ext cx="5631815" cy="2265045"/>
-          </a:xfrm>
-          <a:prstGeom prst="rect">
-            <a:avLst/>
-          </a:prstGeom>
-        </p:spPr>
-      </p:pic>
-      <p:sp>
-        <p:nvSpPr>
-          <p:cNvPr id="5" name="文本框 4"/>
-          <p:cNvSpPr txBox="1"/>
-          <p:nvPr/>
-        </p:nvSpPr>
-        <p:spPr>
-          <a:xfrm>
-            <a:off x="179070" y="7691120"/>
-            <a:ext cx="9707245" cy="2861310"/>
-          </a:xfrm>
-          <a:prstGeom prst="rect">
-            <a:avLst/>
-          </a:prstGeom>
-          <a:noFill/>
-        </p:spPr>
-        <p:txBody>
-          <a:bodyPr wrap="square" rtlCol="0">
-            <a:spAutoFit/>
-          </a:bodyPr>
-          <a:p>
-            <a:pPr marL="285750" indent="-285750">
-              <a:buFont typeface="Arial" panose="020B0604020202020204" pitchFamily="34" charset="0"/>
-              <a:buChar char="•"/>
-            </a:pPr>
-            <a:r>
-              <a:rPr lang="en-US" altLang="zh-CN"/>
-              <a:t>Peaks in coding regions indicate accessibility for the transcription machinery, so these genes may be expressed or prepared for expression in this cell.</a:t>
-            </a:r>
-            <a:endParaRPr lang="en-US" altLang="zh-CN"/>
-          </a:p>
-          <a:p>
-            <a:pPr marL="285750" indent="-285750">
-              <a:buFont typeface="Arial" panose="020B0604020202020204" pitchFamily="34" charset="0"/>
-              <a:buChar char="•"/>
-            </a:pPr>
-            <a:r>
-              <a:rPr lang="en-US" altLang="zh-CN"/>
-              <a:t>Peaks in non-coding regions indicate accessibility for regulatory proteins, such as transcription factors. These regions may thus be active regulatory elements.</a:t>
-            </a:r>
-            <a:endParaRPr lang="en-US" altLang="zh-CN"/>
-          </a:p>
-          <a:p>
-            <a:pPr marL="285750" indent="-285750">
-              <a:buFont typeface="Arial" panose="020B0604020202020204" pitchFamily="34" charset="0"/>
-              <a:buChar char="•"/>
-            </a:pPr>
-            <a:r>
-              <a:rPr lang="en-US" altLang="zh-CN"/>
-              <a:t>A correlation between non-coding regions and coding regions suggests an interplay between regulatory proteins and genes. The non-coding regions may be cis-regulatory elements for the implicated genes, i.e., regions where regulatory proteins bind that affect a neighboring gene’s expression.</a:t>
-            </a:r>
-            <a:endParaRPr lang="en-US" altLang="zh-CN"/>
-          </a:p>
-          <a:p>
-            <a:pPr marL="285750" indent="-285750">
-              <a:buFont typeface="Arial" panose="020B0604020202020204" pitchFamily="34" charset="0"/>
-              <a:buChar char="•"/>
-            </a:pPr>
-            <a:r>
-              <a:rPr lang="en-US" altLang="zh-CN"/>
-              <a:t>Recurring binding motifs in different non-coding regions can imply which regulatory proteins are active in a cell.</a:t>
-            </a:r>
-            <a:endParaRPr lang="en-US" altLang="zh-CN"/>
-          </a:p>
-        </p:txBody>
-      </p:sp>
-      <p:pic>
-        <p:nvPicPr>
-          <p:cNvPr id="6" name="图片 5"/>
-          <p:cNvPicPr>
-            <a:picLocks noChangeAspect="1"/>
-          </p:cNvPicPr>
-          <p:nvPr/>
-        </p:nvPicPr>
-        <p:blipFill>
-          <a:blip r:embed="rId2"/>
-          <a:stretch>
-            <a:fillRect/>
-          </a:stretch>
-        </p:blipFill>
-        <p:spPr>
-          <a:xfrm>
-            <a:off x="6750685" y="1270635"/>
-            <a:ext cx="1927225" cy="2421255"/>
-          </a:xfrm>
-          <a:prstGeom prst="rect">
-            <a:avLst/>
-          </a:prstGeom>
-        </p:spPr>
-      </p:pic>
-      <p:pic>
-        <p:nvPicPr>
-          <p:cNvPr id="3" name="图片 2"/>
-          <p:cNvPicPr>
-            <a:picLocks noChangeAspect="1"/>
-          </p:cNvPicPr>
-          <p:nvPr/>
-        </p:nvPicPr>
-        <p:blipFill>
-          <a:blip r:embed="rId3"/>
-          <a:stretch>
-            <a:fillRect/>
-          </a:stretch>
-        </p:blipFill>
-        <p:spPr>
-          <a:xfrm>
-            <a:off x="1078865" y="3623310"/>
-            <a:ext cx="9170670" cy="2808605"/>
-          </a:xfrm>
-          <a:prstGeom prst="rect">
-            <a:avLst/>
-          </a:prstGeom>
-        </p:spPr>
-      </p:pic>
+              <a:t>What are ACRs and peaks?</a:t>
+            </a:r>
+            <a:endParaRPr lang="en-US" altLang="zh-CN"/>
+          </a:p>
+        </p:txBody>
+      </p:sp>
     </p:spTree>
   </p:cSld>
   <p:clrMapOvr>
@@ -4071,7 +4224,7 @@
           <a:p>
             <a:r>
               <a:rPr lang="en-US" altLang="zh-CN"/>
-              <a:t>ArchR</a:t>
+              <a:t>The distribution of ACRs.</a:t>
             </a:r>
             <a:endParaRPr lang="en-US" altLang="zh-CN"/>
           </a:p>
@@ -4095,115 +4248,8 @@
         </p:blipFill>
         <p:spPr>
           <a:xfrm>
-            <a:off x="88900" y="5746750"/>
-            <a:ext cx="3307715" cy="1169035"/>
-          </a:xfrm>
-          <a:prstGeom prst="rect">
-            <a:avLst/>
-          </a:prstGeom>
-        </p:spPr>
-      </p:pic>
-      <p:sp>
-        <p:nvSpPr>
-          <p:cNvPr id="5" name="文本框 4"/>
-          <p:cNvSpPr txBox="1"/>
-          <p:nvPr/>
-        </p:nvSpPr>
-        <p:spPr>
-          <a:xfrm>
-            <a:off x="3781425" y="6407150"/>
-            <a:ext cx="8759190" cy="368300"/>
-          </a:xfrm>
-          <a:prstGeom prst="rect">
-            <a:avLst/>
-          </a:prstGeom>
-          <a:noFill/>
-        </p:spPr>
-        <p:txBody>
-          <a:bodyPr wrap="square" rtlCol="0">
-            <a:spAutoFit/>
-          </a:bodyPr>
-          <a:p>
-            <a:r>
-              <a:rPr lang="en-US" altLang="zh-CN"/>
-              <a:t>https://www.archrproject.com/bookdown/index.html#section</a:t>
-            </a:r>
-            <a:endParaRPr lang="en-US" altLang="zh-CN"/>
-          </a:p>
-        </p:txBody>
-      </p:sp>
-      <p:sp>
-        <p:nvSpPr>
-          <p:cNvPr id="6" name="文本框 5"/>
-          <p:cNvSpPr txBox="1"/>
-          <p:nvPr/>
-        </p:nvSpPr>
-        <p:spPr>
-          <a:xfrm>
-            <a:off x="617220" y="1158240"/>
-            <a:ext cx="10927080" cy="2306955"/>
-          </a:xfrm>
-          <a:prstGeom prst="rect">
-            <a:avLst/>
-          </a:prstGeom>
-          <a:noFill/>
-        </p:spPr>
-        <p:txBody>
-          <a:bodyPr wrap="square" rtlCol="0">
-            <a:spAutoFit/>
-          </a:bodyPr>
-          <a:p>
-            <a:r>
-              <a:rPr lang="en-US" altLang="zh-CN"/>
-              <a:t>How to create ArrowFiles?</a:t>
-            </a:r>
-            <a:endParaRPr lang="en-US" altLang="zh-CN"/>
-          </a:p>
-          <a:p>
-            <a:r>
-              <a:rPr lang="en-US" altLang="zh-CN"/>
-              <a:t>What are fragments? “fragments” refers to a table or genomic ranges object containing the chromosome, offset-adjusted single-base chromosome start position, offset-adjusted single-base chromosome end position, and unique cellular barcode ID corresponding to each sequenced fragments. </a:t>
-            </a:r>
-            <a:r>
-              <a:rPr lang="en-US" altLang="zh-CN" b="1"/>
-              <a:t>Fragment files</a:t>
-            </a:r>
-            <a:r>
-              <a:rPr lang="en-US" altLang="zh-CN"/>
-              <a:t> are tabix-sorted text files containing each scATAC-seq fragment and the corresponding cell ID, one fragment per line.</a:t>
-            </a:r>
-            <a:endParaRPr lang="en-US" altLang="zh-CN"/>
-          </a:p>
-          <a:p>
-            <a:r>
-              <a:rPr lang="en-US" altLang="zh-CN"/>
-              <a:t>Why we select ArchR? It’s very powerful compared with others including running time and memory resources. But a misery is stoped updated and maintained. If you interesed in python env, maybe snapATAC2 is a better begining.</a:t>
-            </a:r>
-            <a:endParaRPr lang="en-US" altLang="zh-CN"/>
-          </a:p>
-          <a:p>
-            <a:endParaRPr lang="en-US" altLang="zh-CN"/>
-          </a:p>
-        </p:txBody>
-      </p:sp>
-      <p:pic>
-        <p:nvPicPr>
-          <p:cNvPr id="7" name="图片 6"/>
-          <p:cNvPicPr>
-            <a:picLocks noChangeAspect="1"/>
-          </p:cNvPicPr>
-          <p:nvPr/>
-        </p:nvPicPr>
-        <p:blipFill>
-          <a:blip r:embed="rId2"/>
-          <a:stretch>
-            <a:fillRect/>
-          </a:stretch>
-        </p:blipFill>
-        <p:spPr>
-          <a:xfrm>
-            <a:off x="6286500" y="3237230"/>
-            <a:ext cx="5257800" cy="2677795"/>
+            <a:off x="606425" y="1691005"/>
+            <a:ext cx="3543300" cy="3543300"/>
           </a:xfrm>
           <a:prstGeom prst="rect">
             <a:avLst/>
@@ -4238,20 +4284,13 @@
             <p:ph type="title"/>
           </p:nvPr>
         </p:nvSpPr>
-        <p:spPr>
-          <a:xfrm>
-            <a:off x="342265" y="365125"/>
-            <a:ext cx="11461115" cy="1325880"/>
-          </a:xfrm>
-        </p:spPr>
-        <p:txBody>
-          <a:bodyPr>
-            <a:normAutofit/>
-          </a:bodyPr>
-          <a:p>
-            <a:r>
-              <a:rPr lang="en-US" altLang="zh-CN"/>
-              <a:t>ArchRProject: An ArchR object and a directory</a:t>
+        <p:spPr/>
+        <p:txBody>
+          <a:bodyPr/>
+          <a:p>
+            <a:r>
+              <a:rPr lang="en-US" altLang="zh-CN"/>
+              <a:t>ACRs means trascription?</a:t>
             </a:r>
             <a:endParaRPr lang="en-US" altLang="zh-CN"/>
           </a:p>
@@ -4259,11 +4298,13 @@
       </p:sp>
       <p:pic>
         <p:nvPicPr>
-          <p:cNvPr id="5" name="图片 4"/>
+          <p:cNvPr id="4" name="内容占位符 3"/>
           <p:cNvPicPr>
             <a:picLocks noChangeAspect="1"/>
           </p:cNvPicPr>
-          <p:nvPr/>
+          <p:nvPr>
+            <p:ph idx="1"/>
+          </p:nvPr>
         </p:nvPicPr>
         <p:blipFill>
           <a:blip r:embed="rId1"/>
@@ -4273,8 +4314,8 @@
         </p:blipFill>
         <p:spPr>
           <a:xfrm>
-            <a:off x="4406900" y="1478915"/>
-            <a:ext cx="7481570" cy="5042535"/>
+            <a:off x="926465" y="1358265"/>
+            <a:ext cx="5631815" cy="2265045"/>
           </a:xfrm>
           <a:prstGeom prst="rect">
             <a:avLst/>
@@ -4283,14 +4324,14 @@
       </p:pic>
       <p:sp>
         <p:nvSpPr>
-          <p:cNvPr id="6" name="文本框 5"/>
+          <p:cNvPr id="5" name="文本框 4"/>
           <p:cNvSpPr txBox="1"/>
           <p:nvPr/>
         </p:nvSpPr>
         <p:spPr>
           <a:xfrm>
-            <a:off x="342900" y="1828800"/>
-            <a:ext cx="4064000" cy="1198880"/>
+            <a:off x="179070" y="7691120"/>
+            <a:ext cx="9707245" cy="2861310"/>
           </a:xfrm>
           <a:prstGeom prst="rect">
             <a:avLst/>
@@ -4308,7 +4349,7 @@
             </a:pPr>
             <a:r>
               <a:rPr lang="en-US" altLang="zh-CN"/>
-              <a:t>fragments -&gt; arrow files</a:t>
+              <a:t>Peaks in coding regions indicate accessibility for the transcription machinery, so these genes may be expressed or prepared for expression in this cell.</a:t>
             </a:r>
             <a:endParaRPr lang="en-US" altLang="zh-CN"/>
           </a:p>
@@ -4319,7 +4360,7 @@
             </a:pPr>
             <a:r>
               <a:rPr lang="en-US" altLang="zh-CN"/>
-              <a:t>metadata proj@cellColData</a:t>
+              <a:t>Peaks in non-coding regions indicate accessibility for regulatory proteins, such as transcription factors. These regions may thus be active regulatory elements.</a:t>
             </a:r>
             <a:endParaRPr lang="en-US" altLang="zh-CN"/>
           </a:p>
@@ -4330,7 +4371,7 @@
             </a:pPr>
             <a:r>
               <a:rPr lang="en-US" altLang="zh-CN"/>
-              <a:t>matrix getAvailableMatrices(proj)</a:t>
+              <a:t>A correlation between non-coding regions and coding regions suggests an interplay between regulatory proteins and genes. The non-coding regions may be cis-regulatory elements for the implicated genes, i.e., regions where regulatory proteins bind that affect a neighboring gene’s expression.</a:t>
             </a:r>
             <a:endParaRPr lang="en-US" altLang="zh-CN"/>
           </a:p>
@@ -4341,7 +4382,7 @@
             </a:pPr>
             <a:r>
               <a:rPr lang="en-US" altLang="zh-CN"/>
-              <a:t>reduction &amp; embedding</a:t>
+              <a:t>Recurring binding motifs in different non-coding regions can imply which regulatory proteins are active in a cell.</a:t>
             </a:r>
             <a:endParaRPr lang="en-US" altLang="zh-CN"/>
           </a:p>
@@ -4349,7 +4390,7 @@
       </p:sp>
       <p:pic>
         <p:nvPicPr>
-          <p:cNvPr id="8" name="图片 7"/>
+          <p:cNvPr id="6" name="图片 5"/>
           <p:cNvPicPr>
             <a:picLocks noChangeAspect="1"/>
           </p:cNvPicPr>
@@ -4363,8 +4404,32 @@
         </p:blipFill>
         <p:spPr>
           <a:xfrm>
-            <a:off x="181610" y="3743960"/>
-            <a:ext cx="3943985" cy="2588260"/>
+            <a:off x="6750685" y="1270635"/>
+            <a:ext cx="1927225" cy="2421255"/>
+          </a:xfrm>
+          <a:prstGeom prst="rect">
+            <a:avLst/>
+          </a:prstGeom>
+        </p:spPr>
+      </p:pic>
+      <p:pic>
+        <p:nvPicPr>
+          <p:cNvPr id="3" name="图片 2"/>
+          <p:cNvPicPr>
+            <a:picLocks noChangeAspect="1"/>
+          </p:cNvPicPr>
+          <p:nvPr/>
+        </p:nvPicPr>
+        <p:blipFill>
+          <a:blip r:embed="rId3"/>
+          <a:stretch>
+            <a:fillRect/>
+          </a:stretch>
+        </p:blipFill>
+        <p:spPr>
+          <a:xfrm>
+            <a:off x="1078865" y="3623310"/>
+            <a:ext cx="9170670" cy="2808605"/>
           </a:xfrm>
           <a:prstGeom prst="rect">
             <a:avLst/>
@@ -4405,56 +4470,145 @@
           <a:p>
             <a:r>
               <a:rPr lang="en-US" altLang="zh-CN"/>
-              <a:t>Annotations of gene and genome</a:t>
-            </a:r>
-            <a:endParaRPr lang="en-US" altLang="zh-CN"/>
-          </a:p>
-        </p:txBody>
-      </p:sp>
-      <p:sp>
-        <p:nvSpPr>
-          <p:cNvPr id="3" name="内容占位符 2"/>
-          <p:cNvSpPr>
-            <a:spLocks noGrp="1"/>
-          </p:cNvSpPr>
+              <a:t>ArchR</a:t>
+            </a:r>
+            <a:endParaRPr lang="en-US" altLang="zh-CN"/>
+          </a:p>
+        </p:txBody>
+      </p:sp>
+      <p:pic>
+        <p:nvPicPr>
+          <p:cNvPr id="4" name="内容占位符 3"/>
+          <p:cNvPicPr>
+            <a:picLocks noChangeAspect="1"/>
+          </p:cNvPicPr>
           <p:nvPr>
             <p:ph idx="1"/>
           </p:nvPr>
-        </p:nvSpPr>
-        <p:spPr/>
-        <p:txBody>
-          <a:bodyPr/>
-          <a:p>
-            <a:r>
-              <a:rPr lang="en-US" altLang="zh-CN"/>
-              <a:t>ArchR requires gene and genome annotations to do things such as calculate TSS enrichment scores, nucleotide content, and gene activity scores.</a:t>
-            </a:r>
-            <a:endParaRPr lang="en-US" altLang="zh-CN"/>
-          </a:p>
-          <a:p>
-            <a:r>
-              <a:rPr lang="en-US" altLang="zh-CN"/>
-              <a:t>How to custom annotation? (1) from ArchR tutorial </a:t>
-            </a:r>
-            <a:r>
-              <a:rPr lang="en-US" altLang="zh-CN" i="1"/>
-              <a:t>https://www.archrproject.com/bookdown/getting-set-up.html#creating-a-custom-archrgenome</a:t>
-            </a:r>
-            <a:r>
-              <a:rPr lang="en-US" altLang="zh-CN"/>
-              <a:t> (2) from omics4plant </a:t>
-            </a:r>
-            <a:r>
-              <a:rPr lang="en-US" altLang="zh-CN" i="1"/>
-              <a:t>https://github.com/ydgenomics/omics4plant/tree/main/SOFTWARE/ArchR/NOTEs/NOTE-region_annotation</a:t>
-            </a:r>
-            <a:endParaRPr lang="en-US" altLang="zh-CN" i="1"/>
-          </a:p>
-          <a:p>
-            <a:endParaRPr lang="en-US" altLang="zh-CN" i="1"/>
-          </a:p>
-        </p:txBody>
-      </p:sp>
+        </p:nvPicPr>
+        <p:blipFill>
+          <a:blip r:embed="rId1"/>
+          <a:stretch>
+            <a:fillRect/>
+          </a:stretch>
+        </p:blipFill>
+        <p:spPr>
+          <a:xfrm>
+            <a:off x="88900" y="5746750"/>
+            <a:ext cx="3307715" cy="1169035"/>
+          </a:xfrm>
+          <a:prstGeom prst="rect">
+            <a:avLst/>
+          </a:prstGeom>
+        </p:spPr>
+      </p:pic>
+      <p:sp>
+        <p:nvSpPr>
+          <p:cNvPr id="5" name="文本框 4"/>
+          <p:cNvSpPr txBox="1"/>
+          <p:nvPr/>
+        </p:nvSpPr>
+        <p:spPr>
+          <a:xfrm>
+            <a:off x="3781425" y="6407150"/>
+            <a:ext cx="8759190" cy="368300"/>
+          </a:xfrm>
+          <a:prstGeom prst="rect">
+            <a:avLst/>
+          </a:prstGeom>
+          <a:noFill/>
+        </p:spPr>
+        <p:txBody>
+          <a:bodyPr wrap="square" rtlCol="0">
+            <a:spAutoFit/>
+          </a:bodyPr>
+          <a:p>
+            <a:r>
+              <a:rPr lang="en-US" altLang="zh-CN"/>
+              <a:t>https://www.archrproject.com/bookdown/index.html#section</a:t>
+            </a:r>
+            <a:endParaRPr lang="en-US" altLang="zh-CN"/>
+          </a:p>
+        </p:txBody>
+      </p:sp>
+      <p:sp>
+        <p:nvSpPr>
+          <p:cNvPr id="6" name="文本框 5"/>
+          <p:cNvSpPr txBox="1"/>
+          <p:nvPr/>
+        </p:nvSpPr>
+        <p:spPr>
+          <a:xfrm>
+            <a:off x="617220" y="1158240"/>
+            <a:ext cx="10927080" cy="2306955"/>
+          </a:xfrm>
+          <a:prstGeom prst="rect">
+            <a:avLst/>
+          </a:prstGeom>
+          <a:noFill/>
+        </p:spPr>
+        <p:txBody>
+          <a:bodyPr wrap="square" rtlCol="0">
+            <a:spAutoFit/>
+          </a:bodyPr>
+          <a:p>
+            <a:r>
+              <a:rPr lang="en-US" altLang="zh-CN"/>
+              <a:t>How to create ArrowFiles?</a:t>
+            </a:r>
+            <a:endParaRPr lang="en-US" altLang="zh-CN"/>
+          </a:p>
+          <a:p>
+            <a:r>
+              <a:rPr lang="en-US" altLang="zh-CN"/>
+              <a:t>What are fragments? “fragments” refers to a table or genomic ranges object containing the chromosome, offset-adjusted single-base chromosome start position, offset-adjusted single-base chromosome end position, and unique cellular barcode ID corresponding to each sequenced fragments. </a:t>
+            </a:r>
+            <a:r>
+              <a:rPr lang="en-US" altLang="zh-CN" b="1"/>
+              <a:t>Fragment files</a:t>
+            </a:r>
+            <a:r>
+              <a:rPr lang="en-US" altLang="zh-CN"/>
+              <a:t> are tabix-sorted text files containing each scATAC-seq fragment and the corresponding cell ID, one fragment per line.</a:t>
+            </a:r>
+            <a:endParaRPr lang="en-US" altLang="zh-CN"/>
+          </a:p>
+          <a:p>
+            <a:r>
+              <a:rPr lang="en-US" altLang="zh-CN"/>
+              <a:t>Why we select ArchR? It’s very powerful compared with others including running time and memory resources. But a misery is stoped updated and maintained. If you interesed in python env, maybe snapATAC2 is a better begining.</a:t>
+            </a:r>
+            <a:endParaRPr lang="en-US" altLang="zh-CN"/>
+          </a:p>
+          <a:p>
+            <a:endParaRPr lang="en-US" altLang="zh-CN"/>
+          </a:p>
+        </p:txBody>
+      </p:sp>
+      <p:pic>
+        <p:nvPicPr>
+          <p:cNvPr id="7" name="图片 6"/>
+          <p:cNvPicPr>
+            <a:picLocks noChangeAspect="1"/>
+          </p:cNvPicPr>
+          <p:nvPr/>
+        </p:nvPicPr>
+        <p:blipFill>
+          <a:blip r:embed="rId2"/>
+          <a:stretch>
+            <a:fillRect/>
+          </a:stretch>
+        </p:blipFill>
+        <p:spPr>
+          <a:xfrm>
+            <a:off x="6286500" y="3237230"/>
+            <a:ext cx="5257800" cy="2677795"/>
+          </a:xfrm>
+          <a:prstGeom prst="rect">
+            <a:avLst/>
+          </a:prstGeom>
+        </p:spPr>
+      </p:pic>
     </p:spTree>
   </p:cSld>
   <p:clrMapOvr>
@@ -4483,24 +4637,59 @@
             <p:ph type="title"/>
           </p:nvPr>
         </p:nvSpPr>
-        <p:spPr/>
-        <p:txBody>
-          <a:bodyPr/>
-          <a:p>
-            <a:endParaRPr lang="zh-CN" altLang="en-US"/>
-          </a:p>
-        </p:txBody>
-      </p:sp>
-      <p:sp>
-        <p:nvSpPr>
-          <p:cNvPr id="4" name="文本框 3"/>
+        <p:spPr>
+          <a:xfrm>
+            <a:off x="342265" y="365125"/>
+            <a:ext cx="11461115" cy="1325880"/>
+          </a:xfrm>
+        </p:spPr>
+        <p:txBody>
+          <a:bodyPr>
+            <a:normAutofit/>
+          </a:bodyPr>
+          <a:p>
+            <a:r>
+              <a:rPr lang="en-US" altLang="zh-CN"/>
+              <a:t>ArchRProject: An ArchR object and a directory</a:t>
+            </a:r>
+            <a:endParaRPr lang="en-US" altLang="zh-CN"/>
+          </a:p>
+        </p:txBody>
+      </p:sp>
+      <p:pic>
+        <p:nvPicPr>
+          <p:cNvPr id="5" name="图片 4"/>
+          <p:cNvPicPr>
+            <a:picLocks noChangeAspect="1"/>
+          </p:cNvPicPr>
+          <p:nvPr/>
+        </p:nvPicPr>
+        <p:blipFill>
+          <a:blip r:embed="rId1"/>
+          <a:stretch>
+            <a:fillRect/>
+          </a:stretch>
+        </p:blipFill>
+        <p:spPr>
+          <a:xfrm>
+            <a:off x="4406900" y="1478915"/>
+            <a:ext cx="7481570" cy="5042535"/>
+          </a:xfrm>
+          <a:prstGeom prst="rect">
+            <a:avLst/>
+          </a:prstGeom>
+        </p:spPr>
+      </p:pic>
+      <p:sp>
+        <p:nvSpPr>
+          <p:cNvPr id="6" name="文本框 5"/>
           <p:cNvSpPr txBox="1"/>
           <p:nvPr/>
         </p:nvSpPr>
         <p:spPr>
           <a:xfrm>
-            <a:off x="283210" y="2232660"/>
-            <a:ext cx="7928610" cy="4184650"/>
+            <a:off x="342900" y="1828800"/>
+            <a:ext cx="4064000" cy="1198880"/>
           </a:xfrm>
           <a:prstGeom prst="rect">
             <a:avLst/>
@@ -4512,276 +4701,75 @@
             <a:spAutoFit/>
           </a:bodyPr>
           <a:p>
-            <a:r>
-              <a:rPr lang="en-US" altLang="zh-CN" sz="1400"/>
-              <a:t>$ tree -L 2 EFH-0d</a:t>
-            </a:r>
-            <a:endParaRPr lang="en-US" altLang="zh-CN" sz="1400"/>
-          </a:p>
-          <a:p>
-            <a:r>
-              <a:rPr lang="en-US" altLang="zh-CN" sz="1400"/>
-              <a:t>EFH-0d</a:t>
-            </a:r>
-            <a:endParaRPr lang="en-US" altLang="zh-CN" sz="1400"/>
-          </a:p>
-          <a:p>
-            <a:r>
-              <a:rPr lang="en-US" altLang="en-US" sz="1400"/>
-              <a:t>├──</a:t>
-            </a:r>
-            <a:r>
-              <a:rPr lang="en-US" altLang="zh-CN" sz="1400"/>
-              <a:t> ArrowFiles</a:t>
-            </a:r>
-            <a:endParaRPr lang="en-US" altLang="zh-CN" sz="1400"/>
-          </a:p>
-          <a:p>
-            <a:r>
-              <a:rPr lang="en-US" altLang="en-US" sz="1400"/>
-              <a:t>│</a:t>
-            </a:r>
-            <a:r>
-              <a:rPr lang="en-US" altLang="zh-CN" sz="1400"/>
-              <a:t>   </a:t>
-            </a:r>
-            <a:r>
-              <a:rPr lang="en-US" altLang="en-US" sz="1400"/>
-              <a:t>├──</a:t>
-            </a:r>
-            <a:r>
-              <a:rPr lang="en-US" altLang="zh-CN" sz="1400"/>
-              <a:t> EFH-0d-0114-DNA1.arrow</a:t>
-            </a:r>
-            <a:endParaRPr lang="en-US" altLang="zh-CN" sz="1400"/>
-          </a:p>
-          <a:p>
-            <a:r>
-              <a:rPr lang="en-US" altLang="en-US" sz="1400"/>
-              <a:t>│</a:t>
-            </a:r>
-            <a:r>
-              <a:rPr lang="en-US" altLang="zh-CN" sz="1400"/>
-              <a:t>   </a:t>
-            </a:r>
-            <a:r>
-              <a:rPr lang="en-US" altLang="en-US" sz="1400"/>
-              <a:t>├──</a:t>
-            </a:r>
-            <a:r>
-              <a:rPr lang="en-US" altLang="zh-CN" sz="1400"/>
-              <a:t> EFH-0d-0114-DNA2.arrow</a:t>
-            </a:r>
-            <a:endParaRPr lang="en-US" altLang="zh-CN" sz="1400"/>
-          </a:p>
-          <a:p>
-            <a:r>
-              <a:rPr lang="en-US" altLang="en-US" sz="1400"/>
-              <a:t>│</a:t>
-            </a:r>
-            <a:r>
-              <a:rPr lang="en-US" altLang="zh-CN" sz="1400"/>
-              <a:t>   </a:t>
-            </a:r>
-            <a:r>
-              <a:rPr lang="en-US" altLang="en-US" sz="1400"/>
-              <a:t>└──</a:t>
-            </a:r>
-            <a:r>
-              <a:rPr lang="en-US" altLang="zh-CN" sz="1400"/>
-              <a:t> EFH-0d-0114-DNA3.arrow</a:t>
-            </a:r>
-            <a:endParaRPr lang="en-US" altLang="zh-CN" sz="1400"/>
-          </a:p>
-          <a:p>
-            <a:r>
-              <a:rPr lang="en-US" altLang="en-US" sz="1400"/>
-              <a:t>├──</a:t>
-            </a:r>
-            <a:r>
-              <a:rPr lang="en-US" altLang="zh-CN" sz="1400"/>
-              <a:t> Embeddings</a:t>
-            </a:r>
-            <a:endParaRPr lang="en-US" altLang="zh-CN" sz="1400"/>
-          </a:p>
-          <a:p>
-            <a:r>
-              <a:rPr lang="en-US" altLang="en-US" sz="1400"/>
-              <a:t>│</a:t>
-            </a:r>
-            <a:r>
-              <a:rPr lang="en-US" altLang="zh-CN" sz="1400"/>
-              <a:t>   </a:t>
-            </a:r>
-            <a:r>
-              <a:rPr lang="en-US" altLang="en-US" sz="1400"/>
-              <a:t>└──</a:t>
-            </a:r>
-            <a:r>
-              <a:rPr lang="en-US" altLang="zh-CN" sz="1400"/>
-              <a:t> Save-Uwot-UMAP-Params-IterativeLSI-c26739e122b-Date-2026-04-27_Time-13-15-39.tar</a:t>
-            </a:r>
-            <a:endParaRPr lang="en-US" altLang="zh-CN" sz="1400"/>
-          </a:p>
-          <a:p>
-            <a:r>
-              <a:rPr lang="en-US" altLang="en-US" sz="1400"/>
-              <a:t>├──</a:t>
-            </a:r>
-            <a:r>
-              <a:rPr lang="en-US" altLang="zh-CN" sz="1400"/>
-              <a:t> IterativeLSI</a:t>
-            </a:r>
-            <a:endParaRPr lang="en-US" altLang="zh-CN" sz="1400"/>
-          </a:p>
-          <a:p>
-            <a:r>
-              <a:rPr lang="en-US" altLang="en-US" sz="1400"/>
-              <a:t>│</a:t>
-            </a:r>
-            <a:r>
-              <a:rPr lang="en-US" altLang="zh-CN" sz="1400"/>
-              <a:t>   </a:t>
-            </a:r>
-            <a:r>
-              <a:rPr lang="en-US" altLang="en-US" sz="1400"/>
-              <a:t>├──</a:t>
-            </a:r>
-            <a:r>
-              <a:rPr lang="en-US" altLang="zh-CN" sz="1400"/>
-              <a:t> Save-LSI-Iteration-1.pdf</a:t>
-            </a:r>
-            <a:endParaRPr lang="en-US" altLang="zh-CN" sz="1400"/>
-          </a:p>
-          <a:p>
-            <a:r>
-              <a:rPr lang="en-US" altLang="en-US" sz="1400"/>
-              <a:t>│</a:t>
-            </a:r>
-            <a:r>
-              <a:rPr lang="en-US" altLang="zh-CN" sz="1400"/>
-              <a:t>   </a:t>
-            </a:r>
-            <a:r>
-              <a:rPr lang="en-US" altLang="en-US" sz="1400"/>
-              <a:t>└──</a:t>
-            </a:r>
-            <a:r>
-              <a:rPr lang="en-US" altLang="zh-CN" sz="1400"/>
-              <a:t> Save-LSI-Iteration-1.rds</a:t>
-            </a:r>
-            <a:endParaRPr lang="en-US" altLang="zh-CN" sz="1400"/>
-          </a:p>
-          <a:p>
-            <a:r>
-              <a:rPr lang="en-US" altLang="en-US" sz="1400"/>
-              <a:t>├──</a:t>
-            </a:r>
-            <a:r>
-              <a:rPr lang="en-US" altLang="zh-CN" sz="1400"/>
-              <a:t> Plots</a:t>
-            </a:r>
-            <a:endParaRPr lang="en-US" altLang="zh-CN" sz="1400"/>
-          </a:p>
-          <a:p>
-            <a:r>
-              <a:rPr lang="en-US" altLang="en-US" sz="1400"/>
-              <a:t>│</a:t>
-            </a:r>
-            <a:r>
-              <a:rPr lang="en-US" altLang="zh-CN" sz="1400"/>
-              <a:t>   </a:t>
-            </a:r>
-            <a:r>
-              <a:rPr lang="en-US" altLang="en-US" sz="1400"/>
-              <a:t>├──</a:t>
-            </a:r>
-            <a:r>
-              <a:rPr lang="en-US" altLang="zh-CN" sz="1400"/>
-              <a:t> EFH-0d_heatmap_Clusters_vs_Sample.pdf</a:t>
-            </a:r>
-            <a:endParaRPr lang="en-US" altLang="zh-CN" sz="1400"/>
-          </a:p>
-          <a:p>
-            <a:r>
-              <a:rPr lang="en-US" altLang="en-US" sz="1400"/>
-              <a:t>│</a:t>
-            </a:r>
-            <a:r>
-              <a:rPr lang="en-US" altLang="zh-CN" sz="1400"/>
-              <a:t>   </a:t>
-            </a:r>
-            <a:r>
-              <a:rPr lang="en-US" altLang="en-US" sz="1400"/>
-              <a:t>├──</a:t>
-            </a:r>
-            <a:r>
-              <a:rPr lang="en-US" altLang="zh-CN" sz="1400"/>
-              <a:t> EFH-0d_Plot-UMAP-Sample-Clusters.pdf</a:t>
-            </a:r>
-            <a:endParaRPr lang="en-US" altLang="zh-CN" sz="1400"/>
-          </a:p>
-          <a:p>
-            <a:r>
-              <a:rPr lang="en-US" altLang="en-US" sz="1400"/>
-              <a:t>│</a:t>
-            </a:r>
-            <a:r>
-              <a:rPr lang="en-US" altLang="zh-CN" sz="1400"/>
-              <a:t>   </a:t>
-            </a:r>
-            <a:r>
-              <a:rPr lang="en-US" altLang="en-US" sz="1400"/>
-              <a:t>├──</a:t>
-            </a:r>
-            <a:r>
-              <a:rPr lang="en-US" altLang="zh-CN" sz="1400"/>
-              <a:t> EFH-0d_QC-Sample-FragSizes-TSSProfile.pdf</a:t>
-            </a:r>
-            <a:endParaRPr lang="en-US" altLang="zh-CN" sz="1400"/>
-          </a:p>
-          <a:p>
-            <a:r>
-              <a:rPr lang="en-US" altLang="en-US" sz="1400"/>
-              <a:t>│</a:t>
-            </a:r>
-            <a:r>
-              <a:rPr lang="en-US" altLang="zh-CN" sz="1400"/>
-              <a:t>   </a:t>
-            </a:r>
-            <a:r>
-              <a:rPr lang="en-US" altLang="en-US" sz="1400"/>
-              <a:t>└──</a:t>
-            </a:r>
-            <a:r>
-              <a:rPr lang="en-US" altLang="zh-CN" sz="1400"/>
-              <a:t> EFH-0d_QC-Sample-Statistics.pdf</a:t>
-            </a:r>
-            <a:endParaRPr lang="en-US" altLang="zh-CN" sz="1400"/>
-          </a:p>
-          <a:p>
-            <a:r>
-              <a:rPr lang="en-US" altLang="en-US" sz="1400"/>
-              <a:t>└──</a:t>
-            </a:r>
-            <a:r>
-              <a:rPr lang="en-US" altLang="zh-CN" sz="1400"/>
-              <a:t> Save-ArchR-Project.rds</a:t>
-            </a:r>
-            <a:endParaRPr lang="en-US" altLang="zh-CN" sz="1400"/>
-          </a:p>
-          <a:p>
-            <a:endParaRPr lang="en-US" altLang="zh-CN" sz="1400"/>
-          </a:p>
-          <a:p>
-            <a:r>
-              <a:rPr lang="en-US" altLang="zh-CN" sz="1400"/>
-              <a:t>5 directories, 11 files</a:t>
-            </a:r>
-            <a:endParaRPr lang="en-US" altLang="zh-CN" sz="1400"/>
-          </a:p>
-        </p:txBody>
-      </p:sp>
+            <a:pPr marL="285750" indent="-285750">
+              <a:buFont typeface="Arial" panose="020B0604020202020204" pitchFamily="34" charset="0"/>
+              <a:buChar char="•"/>
+            </a:pPr>
+            <a:r>
+              <a:rPr lang="en-US" altLang="zh-CN"/>
+              <a:t>fragments -&gt; arrow files</a:t>
+            </a:r>
+            <a:endParaRPr lang="en-US" altLang="zh-CN"/>
+          </a:p>
+          <a:p>
+            <a:pPr marL="285750" indent="-285750">
+              <a:buFont typeface="Arial" panose="020B0604020202020204" pitchFamily="34" charset="0"/>
+              <a:buChar char="•"/>
+            </a:pPr>
+            <a:r>
+              <a:rPr lang="en-US" altLang="zh-CN"/>
+              <a:t>metadata proj@cellColData</a:t>
+            </a:r>
+            <a:endParaRPr lang="en-US" altLang="zh-CN"/>
+          </a:p>
+          <a:p>
+            <a:pPr marL="285750" indent="-285750">
+              <a:buFont typeface="Arial" panose="020B0604020202020204" pitchFamily="34" charset="0"/>
+              <a:buChar char="•"/>
+            </a:pPr>
+            <a:r>
+              <a:rPr lang="en-US" altLang="zh-CN"/>
+              <a:t>matrix getAvailableMatrices(proj)</a:t>
+            </a:r>
+            <a:endParaRPr lang="en-US" altLang="zh-CN"/>
+          </a:p>
+          <a:p>
+            <a:pPr marL="285750" indent="-285750">
+              <a:buFont typeface="Arial" panose="020B0604020202020204" pitchFamily="34" charset="0"/>
+              <a:buChar char="•"/>
+            </a:pPr>
+            <a:r>
+              <a:rPr lang="en-US" altLang="zh-CN"/>
+              <a:t>reduction &amp; embedding</a:t>
+            </a:r>
+            <a:endParaRPr lang="en-US" altLang="zh-CN"/>
+          </a:p>
+        </p:txBody>
+      </p:sp>
+      <p:pic>
+        <p:nvPicPr>
+          <p:cNvPr id="8" name="图片 7"/>
+          <p:cNvPicPr>
+            <a:picLocks noChangeAspect="1"/>
+          </p:cNvPicPr>
+          <p:nvPr/>
+        </p:nvPicPr>
+        <p:blipFill>
+          <a:blip r:embed="rId2"/>
+          <a:stretch>
+            <a:fillRect/>
+          </a:stretch>
+        </p:blipFill>
+        <p:spPr>
+          <a:xfrm>
+            <a:off x="181610" y="3743960"/>
+            <a:ext cx="3943985" cy="2588260"/>
+          </a:xfrm>
+          <a:prstGeom prst="rect">
+            <a:avLst/>
+          </a:prstGeom>
+        </p:spPr>
+      </p:pic>
     </p:spTree>
   </p:cSld>
   <p:clrMapOvr>

</xml_diff>